<commit_message>
Correct final presentation and poster updates
</commit_message>
<xml_diff>
--- a/deliverables/Group 20C - Final Poster.pptx
+++ b/deliverables/Group 20C - Final Poster.pptx
@@ -5769,52 +5769,14 @@
           </a:bodyPr>
           <a:lstStyle/>
           <a:p>
-            <a:pPr indent="0" lvl="0" marL="0" marR="0" rtl="0" algn="ctr">
-              <a:spcBef>
-                <a:spcPts val="0"/>
-              </a:spcBef>
-              <a:spcAft>
-                <a:spcPts val="0"/>
-              </a:spcAft>
-              <a:buNone/>
-            </a:pPr>
             <a:r>
-              <a:rPr b="1" lang="en" sz="1000">
-                <a:solidFill>
-                  <a:srgbClr val="224070"/>
-                </a:solidFill>
-                <a:latin typeface="Arial"/>
-                <a:ea typeface="Arial"/>
-                <a:cs typeface="Arial"/>
-                <a:sym typeface="Arial"/>
-              </a:rPr>
-              <a:t>Model</a:t>
+              <a:t>Models</a:t>
             </a:r>
-            <a:endParaRPr sz="1100"/>
           </a:p>
           <a:p>
-            <a:pPr indent="0" lvl="0" marL="0" marR="0" rtl="0" algn="l">
-              <a:spcBef>
-                <a:spcPts val="500"/>
-              </a:spcBef>
-              <a:spcAft>
-                <a:spcPts val="0"/>
-              </a:spcAft>
-              <a:buNone/>
-            </a:pPr>
             <a:r>
-              <a:rPr lang="en" sz="800">
-                <a:solidFill>
-                  <a:srgbClr val="232323"/>
-                </a:solidFill>
-                <a:latin typeface="Arial"/>
-                <a:ea typeface="Arial"/>
-                <a:cs typeface="Arial"/>
-                <a:sym typeface="Arial"/>
-              </a:rPr>
-              <a:t>TF-IDF + Logistic Regression. Compared against Linear SVM, Naive Bayes, Decision Tree, and Random Forest.</a:t>
+              <a:t>Model 1: TF-IDF + Logistic Regression detects Dark vs Not Dark. Model 2: TF-IDF + Linear SVM predicts likely type.</a:t>
             </a:r>
-            <a:endParaRPr sz="1100"/>
           </a:p>
         </p:txBody>
       </p:sp>
@@ -5858,52 +5820,14 @@
           </a:bodyPr>
           <a:lstStyle/>
           <a:p>
-            <a:pPr indent="0" lvl="0" marL="0" marR="0" rtl="0" algn="ctr">
-              <a:spcBef>
-                <a:spcPts val="0"/>
-              </a:spcBef>
-              <a:spcAft>
-                <a:spcPts val="0"/>
-              </a:spcAft>
-              <a:buNone/>
-            </a:pPr>
             <a:r>
-              <a:rPr b="1" lang="en" sz="1000">
-                <a:solidFill>
-                  <a:srgbClr val="224070"/>
-                </a:solidFill>
-                <a:latin typeface="Arial"/>
-                <a:ea typeface="Arial"/>
-                <a:cs typeface="Arial"/>
-                <a:sym typeface="Arial"/>
-              </a:rPr>
-              <a:t>Result</a:t>
+              <a:t>Results</a:t>
             </a:r>
-            <a:endParaRPr sz="1100"/>
           </a:p>
           <a:p>
-            <a:pPr indent="0" lvl="0" marL="0" marR="0" rtl="0" algn="l">
-              <a:spcBef>
-                <a:spcPts val="500"/>
-              </a:spcBef>
-              <a:spcAft>
-                <a:spcPts val="0"/>
-              </a:spcAft>
-              <a:buNone/>
-            </a:pPr>
             <a:r>
-              <a:rPr lang="en" sz="800">
-                <a:solidFill>
-                  <a:srgbClr val="232323"/>
-                </a:solidFill>
-                <a:latin typeface="Arial"/>
-                <a:ea typeface="Arial"/>
-                <a:cs typeface="Arial"/>
-                <a:sym typeface="Arial"/>
-              </a:rPr>
-              <a:t>Best primary model: 93.9% accuracy, 0.936 F1.</a:t>
+              <a:t>Model 1: 93.9% accuracy, 0.936 F1. Model 2: 0.894 macro F1 for category/type recognition.</a:t>
             </a:r>
-            <a:endParaRPr sz="1100"/>
           </a:p>
         </p:txBody>
       </p:sp>
@@ -6305,9 +6229,151 @@
           </a:p>
         </p:txBody>
       </p:sp>
+      <p:pic>
+        <p:nvPicPr>
+          <p:cNvPr id="68" name="Picture 67" descr="two_model_summary_card.png"/>
+          <p:cNvPicPr>
+            <a:picLocks noChangeAspect="1"/>
+          </p:cNvPicPr>
+          <p:nvPr/>
+        </p:nvPicPr>
+        <p:blipFill>
+          <a:blip r:embed="rId6"/>
+          <a:stretch>
+            <a:fillRect/>
+          </a:stretch>
+        </p:blipFill>
+        <p:spPr>
+          <a:xfrm>
+            <a:off x="5897880" y="4096512"/>
+            <a:ext cx="2423160" cy="1211580"/>
+          </a:xfrm>
+          <a:prstGeom prst="rect">
+            <a:avLst/>
+          </a:prstGeom>
+        </p:spPr>
+      </p:pic>
+      <p:pic>
+        <p:nvPicPr>
+          <p:cNvPr id="72" name="Picture 71" descr="image.png"/>
+          <p:cNvPicPr>
+            <a:picLocks noChangeAspect="1"/>
+          </p:cNvPicPr>
+          <p:nvPr/>
+        </p:nvPicPr>
+        <p:blipFill>
+          <a:blip r:embed="rId6"/>
+          <a:stretch>
+            <a:fillRect/>
+          </a:stretch>
+        </p:blipFill>
+        <p:spPr>
+          <a:xfrm>
+            <a:off x="5897880" y="4096512"/>
+            <a:ext cx="2423160" cy="1211580"/>
+          </a:xfrm>
+          <a:prstGeom prst="rect">
+            <a:avLst/>
+          </a:prstGeom>
+        </p:spPr>
+      </p:pic>
+      <p:pic>
+        <p:nvPicPr>
+          <p:cNvPr id="76" name="Picture 75" descr="image.png"/>
+          <p:cNvPicPr>
+            <a:picLocks noChangeAspect="1"/>
+          </p:cNvPicPr>
+          <p:nvPr/>
+        </p:nvPicPr>
+        <p:blipFill>
+          <a:blip r:embed="rId6"/>
+          <a:stretch>
+            <a:fillRect/>
+          </a:stretch>
+        </p:blipFill>
+        <p:spPr>
+          <a:xfrm>
+            <a:off x="5897880" y="4096512"/>
+            <a:ext cx="2423160" cy="1211580"/>
+          </a:xfrm>
+          <a:prstGeom prst="rect">
+            <a:avLst/>
+          </a:prstGeom>
+        </p:spPr>
+      </p:pic>
       <p:sp>
         <p:nvSpPr>
-          <p:cNvPr id="67" name="TextBox 66"/>
+          <p:cNvPr id="77" name="TextBox 76"/>
+          <p:cNvSpPr txBox="1"/>
+          <p:nvPr/>
+        </p:nvSpPr>
+        <p:spPr>
+          <a:xfrm>
+            <a:off x="5440680" y="411480"/>
+            <a:ext cx="2606040" cy="320040"/>
+          </a:xfrm>
+          <a:prstGeom prst="rect">
+            <a:avLst/>
+          </a:prstGeom>
+          <a:noFill/>
+        </p:spPr>
+        <p:txBody>
+          <a:bodyPr wrap="none">
+            <a:spAutoFit/>
+          </a:bodyPr>
+          <a:lstStyle/>
+          <a:p>
+            <a:pPr>
+              <a:defRPr sz="1200" b="1">
+                <a:solidFill>
+                  <a:srgbClr val="0F172A"/>
+                </a:solidFill>
+              </a:defRPr>
+            </a:pPr>
+            <a:r>
+              <a:t>Updated: Two Trained Models</a:t>
+            </a:r>
+          </a:p>
+        </p:txBody>
+      </p:sp>
+      <p:sp>
+        <p:nvSpPr>
+          <p:cNvPr id="78" name="TextBox 77"/>
+          <p:cNvSpPr txBox="1"/>
+          <p:nvPr/>
+        </p:nvSpPr>
+        <p:spPr>
+          <a:xfrm>
+            <a:off x="5440680" y="749808"/>
+            <a:ext cx="2606040" cy="749808"/>
+          </a:xfrm>
+          <a:prstGeom prst="rect">
+            <a:avLst/>
+          </a:prstGeom>
+          <a:noFill/>
+        </p:spPr>
+        <p:txBody>
+          <a:bodyPr wrap="none">
+            <a:spAutoFit/>
+          </a:bodyPr>
+          <a:lstStyle/>
+          <a:p>
+            <a:pPr>
+              <a:defRPr sz="800" b="0">
+                <a:solidFill>
+                  <a:srgbClr val="1E293B"/>
+                </a:solidFill>
+              </a:defRPr>
+            </a:pPr>
+            <a:r>
+              <a:t>Model 1 detects Dark vs Not Dark (F1 0.936). Model 2 predicts likely type with Linear SVM (macro F1 0.894).</a:t>
+            </a:r>
+          </a:p>
+        </p:txBody>
+      </p:sp>
+      <p:sp>
+        <p:nvSpPr>
+          <p:cNvPr id="79" name="TextBox 78"/>
           <p:cNvSpPr txBox="1"/>
           <p:nvPr/>
         </p:nvSpPr>
@@ -6342,136 +6408,7 @@
       </p:sp>
       <p:pic>
         <p:nvPicPr>
-          <p:cNvPr id="68" name="Picture 67" descr="two_model_summary_card.png"/>
-          <p:cNvPicPr>
-            <a:picLocks noChangeAspect="1"/>
-          </p:cNvPicPr>
-          <p:nvPr/>
-        </p:nvPicPr>
-        <p:blipFill>
-          <a:blip r:embed="rId6"/>
-          <a:stretch>
-            <a:fillRect/>
-          </a:stretch>
-        </p:blipFill>
-        <p:spPr>
-          <a:xfrm>
-            <a:off x="5897880" y="4096512"/>
-            <a:ext cx="2423160" cy="1211580"/>
-          </a:xfrm>
-          <a:prstGeom prst="rect">
-            <a:avLst/>
-          </a:prstGeom>
-        </p:spPr>
-      </p:pic>
-      <p:sp>
-        <p:nvSpPr>
-          <p:cNvPr id="69" name="TextBox 68"/>
-          <p:cNvSpPr txBox="1"/>
-          <p:nvPr/>
-        </p:nvSpPr>
-        <p:spPr>
-          <a:xfrm>
-            <a:off x="5440680" y="411480"/>
-            <a:ext cx="2606040" cy="320040"/>
-          </a:xfrm>
-          <a:prstGeom prst="rect">
-            <a:avLst/>
-          </a:prstGeom>
-          <a:noFill/>
-        </p:spPr>
-        <p:txBody>
-          <a:bodyPr wrap="none">
-            <a:spAutoFit/>
-          </a:bodyPr>
-          <a:lstStyle/>
-          <a:p>
-            <a:pPr>
-              <a:defRPr sz="1200" b="1">
-                <a:solidFill>
-                  <a:srgbClr val="0F172A"/>
-                </a:solidFill>
-              </a:defRPr>
-            </a:pPr>
-            <a:r>
-              <a:t>Updated: Two Trained Models</a:t>
-            </a:r>
-          </a:p>
-        </p:txBody>
-      </p:sp>
-      <p:sp>
-        <p:nvSpPr>
-          <p:cNvPr id="70" name="TextBox 69"/>
-          <p:cNvSpPr txBox="1"/>
-          <p:nvPr/>
-        </p:nvSpPr>
-        <p:spPr>
-          <a:xfrm>
-            <a:off x="5440680" y="749808"/>
-            <a:ext cx="2606040" cy="749808"/>
-          </a:xfrm>
-          <a:prstGeom prst="rect">
-            <a:avLst/>
-          </a:prstGeom>
-          <a:noFill/>
-        </p:spPr>
-        <p:txBody>
-          <a:bodyPr wrap="none">
-            <a:spAutoFit/>
-          </a:bodyPr>
-          <a:lstStyle/>
-          <a:p>
-            <a:pPr>
-              <a:defRPr sz="800" b="0">
-                <a:solidFill>
-                  <a:srgbClr val="1E293B"/>
-                </a:solidFill>
-              </a:defRPr>
-            </a:pPr>
-            <a:r>
-              <a:t>Model 1 detects Dark vs Not Dark (F1 0.936). Model 2 predicts likely type with Linear SVM (macro F1 0.894).</a:t>
-            </a:r>
-          </a:p>
-        </p:txBody>
-      </p:sp>
-      <p:sp>
-        <p:nvSpPr>
-          <p:cNvPr id="71" name="TextBox 70"/>
-          <p:cNvSpPr txBox="1"/>
-          <p:nvPr/>
-        </p:nvSpPr>
-        <p:spPr>
-          <a:xfrm>
-            <a:off x="6172200" y="3794760"/>
-            <a:ext cx="2148840" cy="310896"/>
-          </a:xfrm>
-          <a:prstGeom prst="rect">
-            <a:avLst/>
-          </a:prstGeom>
-          <a:noFill/>
-        </p:spPr>
-        <p:txBody>
-          <a:bodyPr wrap="none">
-            <a:spAutoFit/>
-          </a:bodyPr>
-          <a:lstStyle/>
-          <a:p>
-            <a:pPr>
-              <a:defRPr sz="1200" b="1">
-                <a:solidFill>
-                  <a:srgbClr val="0F172A"/>
-                </a:solidFill>
-              </a:defRPr>
-            </a:pPr>
-            <a:r>
-              <a:t>Two-Model Demo Flow</a:t>
-            </a:r>
-          </a:p>
-        </p:txBody>
-      </p:sp>
-      <p:pic>
-        <p:nvPicPr>
-          <p:cNvPr id="72" name="Picture 71" descr="image.png"/>
+          <p:cNvPr id="80" name="Picture 79" descr="image.png"/>
           <p:cNvPicPr>
             <a:picLocks noChangeAspect="1"/>
           </p:cNvPicPr>

</xml_diff>